<commit_message>
slides(gemini-enterprise-agents): fix ch02 G0 blockers — add Package+Rollback to slide 10, fix slide 14 attribution
Closes KOEA-8288. Two G0 blockers from KOEA-8017:
- Slide 10: title updated to "The Six Lifecycle Steps"; added Package bullet
  (first) and Rollback bullet (last) to complete the full 6-step lifecycle;
  bullets positioned above the existing rounded-rect flow diagram
- Slide 14: removed duplicate plain "academy.kspl.tech" text box; only the
  full-form "academy.kspl.tech | Koenig AI Academy" attribution remains

Co-Authored-By: Claude Sonnet 4.6 <noreply@anthropic.com>
</commit_message>
<xml_diff>
--- a/vault/courses/gemini-enterprise-agents/ch02-slides.pptx
+++ b/vault/courses/gemini-enterprise-agents/ch02-slides.pptx
@@ -4695,7 +4695,7 @@
                   <a:srgbClr val="FFFFFF"/>
                 </a:solidFill>
               </a:rPr>
-              <a:t>The Five Lifecycle Steps</a:t>
+              <a:t>The Six Lifecycle Steps</a:t>
             </a:r>
           </a:p>
         </p:txBody>
@@ -4735,14 +4735,14 @@
       </p:sp>
       <p:sp>
         <p:nvSpPr>
-          <p:cNvPr id="5" name="TextBox 4"/>
+          <p:cNvPr id="6" name="TextBox 5"/>
           <p:cNvSpPr txBox="1"/>
           <p:nvPr/>
         </p:nvSpPr>
         <p:spPr>
           <a:xfrm>
-            <a:off x="548640" y="1325880"/>
-            <a:ext cx="11064240" cy="4937760"/>
+            <a:off x="457200" y="6446520"/>
+            <a:ext cx="11247120" cy="274320"/>
           </a:xfrm>
           <a:prstGeom prst="rect">
             <a:avLst/>
@@ -4755,77 +4755,588 @@
           </a:bodyPr>
           <a:lstStyle/>
           <a:p>
-            <a:pPr>
-              <a:spcBef>
-                <a:spcPts val="1000"/>
-              </a:spcBef>
-            </a:pPr>
-            <a:r>
-              <a:rPr sz="1800" b="0">
+            <a:pPr algn="l"/>
+            <a:r>
+              <a:rPr sz="900" b="0">
+                <a:solidFill>
+                  <a:srgbClr val="A1A1AA"/>
+                </a:solidFill>
+              </a:rPr>
+              <a:t>academy.kspl.tech | Koenig AI Academy</a:t>
+            </a:r>
+          </a:p>
+        </p:txBody>
+      </p:sp>
+      <p:sp>
+        <p:nvSpPr>
+          <p:cNvPr id="7" name="Rounded Rectangle 6"/>
+          <p:cNvSpPr/>
+          <p:nvPr/>
+        </p:nvSpPr>
+        <p:spPr>
+          <a:xfrm>
+            <a:off x="895760" y="3650000"/>
+            <a:ext cx="1420000" cy="950000"/>
+          </a:xfrm>
+          <a:prstGeom prst="roundRect">
+            <a:avLst/>
+          </a:prstGeom>
+          <a:solidFill>
+            <a:srgbClr val="6366F1"/>
+          </a:solidFill>
+          <a:ln>
+            <a:solidFill>
+              <a:srgbClr val="6366F1"/>
+            </a:solidFill>
+          </a:ln>
+        </p:spPr>
+        <p:style>
+          <a:lnRef idx="1">
+            <a:schemeClr val="accent1"/>
+          </a:lnRef>
+          <a:fillRef idx="3">
+            <a:schemeClr val="accent1"/>
+          </a:fillRef>
+          <a:effectRef idx="2">
+            <a:schemeClr val="accent1"/>
+          </a:effectRef>
+          <a:fontRef idx="minor">
+            <a:schemeClr val="lt1"/>
+          </a:fontRef>
+        </p:style>
+        <p:txBody>
+          <a:bodyPr rtlCol="0" anchor="ctr" wrap="square"/>
+          <a:lstStyle/>
+          <a:p>
+            <a:pPr algn="ctr"/>
+            <a:r>
+              <a:rPr sz="1300" b="1">
                 <a:solidFill>
                   <a:srgbClr val="FFFFFF"/>
                 </a:solidFill>
               </a:rPr>
-              <a:t>▸  Create — deploy the wheel as a new agent resource; save resource_name</a:t>
-            </a:r>
-          </a:p>
-          <a:p>
-            <a:pPr>
-              <a:spcBef>
-                <a:spcPts val="1000"/>
-              </a:spcBef>
-            </a:pPr>
-            <a:r>
-              <a:rPr sz="1800" b="0">
-                <a:solidFill>
-                  <a:srgbClr val="FFFFFF"/>
-                </a:solidFill>
-              </a:rPr>
-              <a:t>▸  Query — remote_agent.query() for sync; stream_query for streaming response as events arrive</a:t>
-            </a:r>
-          </a:p>
-          <a:p>
-            <a:pPr>
-              <a:spcBef>
-                <a:spcPts val="1000"/>
-              </a:spcBef>
-            </a:pPr>
-            <a:r>
-              <a:rPr sz="1800" b="0">
-                <a:solidFill>
-                  <a:srgbClr val="FFFFFF"/>
-                </a:solidFill>
-              </a:rPr>
-              <a:t>▸  Update — push new wheel and pinned requirements when agent logic changes</a:t>
-            </a:r>
-          </a:p>
-          <a:p>
-            <a:pPr>
-              <a:spcBef>
-                <a:spcPts val="1000"/>
-              </a:spcBef>
-            </a:pPr>
-            <a:r>
-              <a:rPr sz="1800" b="0">
-                <a:solidFill>
-                  <a:srgbClr val="FFFFFF"/>
-                </a:solidFill>
-              </a:rPr>
-              <a:t>▸  Delete — retire the compute resource; session records persist separately and must be deleted via the sessions API</a:t>
-            </a:r>
-          </a:p>
-        </p:txBody>
-      </p:sp>
-      <p:sp>
-        <p:nvSpPr>
-          <p:cNvPr id="6" name="TextBox 5"/>
+              <a:t>Package</a:t>
+            </a:r>
+          </a:p>
+          <a:p>
+            <a:pPr algn="ctr"/>
+            <a:r>
+              <a:rPr sz="800">
+                <a:solidFill>
+                  <a:srgbClr val="E5E7EB"/>
+                </a:solidFill>
+              </a:rPr>
+              <a:t>AdkApp
++ reqs</a:t>
+            </a:r>
+          </a:p>
+        </p:txBody>
+      </p:sp>
+      <p:sp>
+        <p:nvSpPr>
+          <p:cNvPr id="8" name="TextBox 7"/>
           <p:cNvSpPr txBox="1"/>
           <p:nvPr/>
         </p:nvSpPr>
         <p:spPr>
           <a:xfrm>
-            <a:off x="457200" y="6446520"/>
-            <a:ext cx="11247120" cy="274320"/>
+            <a:off x="2345760" y="3945000"/>
+            <a:ext cx="310000" cy="360000"/>
+          </a:xfrm>
+          <a:prstGeom prst="rect">
+            <a:avLst/>
+          </a:prstGeom>
+          <a:noFill/>
+        </p:spPr>
+        <p:txBody>
+          <a:bodyPr wrap="none">
+            <a:spAutoFit/>
+          </a:bodyPr>
+          <a:lstStyle/>
+          <a:p>
+            <a:pPr algn="ctr"/>
+            <a:r>
+              <a:rPr sz="2000">
+                <a:solidFill>
+                  <a:srgbClr val="6B7280"/>
+                </a:solidFill>
+              </a:rPr>
+              <a:t>→</a:t>
+            </a:r>
+          </a:p>
+        </p:txBody>
+      </p:sp>
+      <p:sp>
+        <p:nvSpPr>
+          <p:cNvPr id="9" name="Rounded Rectangle 8"/>
+          <p:cNvSpPr/>
+          <p:nvPr/>
+        </p:nvSpPr>
+        <p:spPr>
+          <a:xfrm>
+            <a:off x="2685760" y="3650000"/>
+            <a:ext cx="1420000" cy="950000"/>
+          </a:xfrm>
+          <a:prstGeom prst="roundRect">
+            <a:avLst/>
+          </a:prstGeom>
+          <a:solidFill>
+            <a:srgbClr val="6366F1"/>
+          </a:solidFill>
+          <a:ln>
+            <a:solidFill>
+              <a:srgbClr val="6366F1"/>
+            </a:solidFill>
+          </a:ln>
+        </p:spPr>
+        <p:style>
+          <a:lnRef idx="1">
+            <a:schemeClr val="accent1"/>
+          </a:lnRef>
+          <a:fillRef idx="3">
+            <a:schemeClr val="accent1"/>
+          </a:fillRef>
+          <a:effectRef idx="2">
+            <a:schemeClr val="accent1"/>
+          </a:effectRef>
+          <a:fontRef idx="minor">
+            <a:schemeClr val="lt1"/>
+          </a:fontRef>
+        </p:style>
+        <p:txBody>
+          <a:bodyPr rtlCol="0" anchor="ctr" wrap="square"/>
+          <a:lstStyle/>
+          <a:p>
+            <a:pPr algn="ctr"/>
+            <a:r>
+              <a:rPr sz="1300" b="1">
+                <a:solidFill>
+                  <a:srgbClr val="FFFFFF"/>
+                </a:solidFill>
+              </a:rPr>
+              <a:t>Create</a:t>
+            </a:r>
+          </a:p>
+          <a:p>
+            <a:pPr algn="ctr"/>
+            <a:r>
+              <a:rPr sz="800">
+                <a:solidFill>
+                  <a:srgbClr val="E5E7EB"/>
+                </a:solidFill>
+              </a:rPr>
+              <a:t>.create()
+save name</a:t>
+            </a:r>
+          </a:p>
+        </p:txBody>
+      </p:sp>
+      <p:sp>
+        <p:nvSpPr>
+          <p:cNvPr id="10" name="TextBox 9"/>
+          <p:cNvSpPr txBox="1"/>
+          <p:nvPr/>
+        </p:nvSpPr>
+        <p:spPr>
+          <a:xfrm>
+            <a:off x="4135760" y="3945000"/>
+            <a:ext cx="310000" cy="360000"/>
+          </a:xfrm>
+          <a:prstGeom prst="rect">
+            <a:avLst/>
+          </a:prstGeom>
+          <a:noFill/>
+        </p:spPr>
+        <p:txBody>
+          <a:bodyPr wrap="none">
+            <a:spAutoFit/>
+          </a:bodyPr>
+          <a:lstStyle/>
+          <a:p>
+            <a:pPr algn="ctr"/>
+            <a:r>
+              <a:rPr sz="2000">
+                <a:solidFill>
+                  <a:srgbClr val="6B7280"/>
+                </a:solidFill>
+              </a:rPr>
+              <a:t>→</a:t>
+            </a:r>
+          </a:p>
+        </p:txBody>
+      </p:sp>
+      <p:sp>
+        <p:nvSpPr>
+          <p:cNvPr id="11" name="Rounded Rectangle 10"/>
+          <p:cNvSpPr/>
+          <p:nvPr/>
+        </p:nvSpPr>
+        <p:spPr>
+          <a:xfrm>
+            <a:off x="4475760" y="3650000"/>
+            <a:ext cx="1420000" cy="950000"/>
+          </a:xfrm>
+          <a:prstGeom prst="roundRect">
+            <a:avLst/>
+          </a:prstGeom>
+          <a:solidFill>
+            <a:srgbClr val="6366F1"/>
+          </a:solidFill>
+          <a:ln>
+            <a:solidFill>
+              <a:srgbClr val="6366F1"/>
+            </a:solidFill>
+          </a:ln>
+        </p:spPr>
+        <p:style>
+          <a:lnRef idx="1">
+            <a:schemeClr val="accent1"/>
+          </a:lnRef>
+          <a:fillRef idx="3">
+            <a:schemeClr val="accent1"/>
+          </a:fillRef>
+          <a:effectRef idx="2">
+            <a:schemeClr val="accent1"/>
+          </a:effectRef>
+          <a:fontRef idx="minor">
+            <a:schemeClr val="lt1"/>
+          </a:fontRef>
+        </p:style>
+        <p:txBody>
+          <a:bodyPr rtlCol="0" anchor="ctr" wrap="square"/>
+          <a:lstStyle/>
+          <a:p>
+            <a:pPr algn="ctr"/>
+            <a:r>
+              <a:rPr sz="1300" b="1">
+                <a:solidFill>
+                  <a:srgbClr val="FFFFFF"/>
+                </a:solidFill>
+              </a:rPr>
+              <a:t>Query</a:t>
+            </a:r>
+          </a:p>
+          <a:p>
+            <a:pPr algn="ctr"/>
+            <a:r>
+              <a:rPr sz="800">
+                <a:solidFill>
+                  <a:srgbClr val="E5E7EB"/>
+                </a:solidFill>
+              </a:rPr>
+              <a:t>.query()
+/ stream</a:t>
+            </a:r>
+          </a:p>
+        </p:txBody>
+      </p:sp>
+      <p:sp>
+        <p:nvSpPr>
+          <p:cNvPr id="12" name="TextBox 11"/>
+          <p:cNvSpPr txBox="1"/>
+          <p:nvPr/>
+        </p:nvSpPr>
+        <p:spPr>
+          <a:xfrm>
+            <a:off x="5925760" y="3945000"/>
+            <a:ext cx="310000" cy="360000"/>
+          </a:xfrm>
+          <a:prstGeom prst="rect">
+            <a:avLst/>
+          </a:prstGeom>
+          <a:noFill/>
+        </p:spPr>
+        <p:txBody>
+          <a:bodyPr wrap="none">
+            <a:spAutoFit/>
+          </a:bodyPr>
+          <a:lstStyle/>
+          <a:p>
+            <a:pPr algn="ctr"/>
+            <a:r>
+              <a:rPr sz="2000">
+                <a:solidFill>
+                  <a:srgbClr val="6B7280"/>
+                </a:solidFill>
+              </a:rPr>
+              <a:t>→</a:t>
+            </a:r>
+          </a:p>
+        </p:txBody>
+      </p:sp>
+      <p:sp>
+        <p:nvSpPr>
+          <p:cNvPr id="13" name="Rounded Rectangle 12"/>
+          <p:cNvSpPr/>
+          <p:nvPr/>
+        </p:nvSpPr>
+        <p:spPr>
+          <a:xfrm>
+            <a:off x="6265760" y="3650000"/>
+            <a:ext cx="1420000" cy="950000"/>
+          </a:xfrm>
+          <a:prstGeom prst="roundRect">
+            <a:avLst/>
+          </a:prstGeom>
+          <a:solidFill>
+            <a:srgbClr val="6366F1"/>
+          </a:solidFill>
+          <a:ln>
+            <a:solidFill>
+              <a:srgbClr val="6366F1"/>
+            </a:solidFill>
+          </a:ln>
+        </p:spPr>
+        <p:style>
+          <a:lnRef idx="1">
+            <a:schemeClr val="accent1"/>
+          </a:lnRef>
+          <a:fillRef idx="3">
+            <a:schemeClr val="accent1"/>
+          </a:fillRef>
+          <a:effectRef idx="2">
+            <a:schemeClr val="accent1"/>
+          </a:effectRef>
+          <a:fontRef idx="minor">
+            <a:schemeClr val="lt1"/>
+          </a:fontRef>
+        </p:style>
+        <p:txBody>
+          <a:bodyPr rtlCol="0" anchor="ctr" wrap="square"/>
+          <a:lstStyle/>
+          <a:p>
+            <a:pPr algn="ctr"/>
+            <a:r>
+              <a:rPr sz="1300" b="1">
+                <a:solidFill>
+                  <a:srgbClr val="FFFFFF"/>
+                </a:solidFill>
+              </a:rPr>
+              <a:t>Update</a:t>
+            </a:r>
+          </a:p>
+          <a:p>
+            <a:pPr algn="ctr"/>
+            <a:r>
+              <a:rPr sz="800">
+                <a:solidFill>
+                  <a:srgbClr val="E5E7EB"/>
+                </a:solidFill>
+              </a:rPr>
+              <a:t>.update()
+new runtime</a:t>
+            </a:r>
+          </a:p>
+        </p:txBody>
+      </p:sp>
+      <p:sp>
+        <p:nvSpPr>
+          <p:cNvPr id="14" name="TextBox 13"/>
+          <p:cNvSpPr txBox="1"/>
+          <p:nvPr/>
+        </p:nvSpPr>
+        <p:spPr>
+          <a:xfrm>
+            <a:off x="7715760" y="3945000"/>
+            <a:ext cx="310000" cy="360000"/>
+          </a:xfrm>
+          <a:prstGeom prst="rect">
+            <a:avLst/>
+          </a:prstGeom>
+          <a:noFill/>
+        </p:spPr>
+        <p:txBody>
+          <a:bodyPr wrap="none">
+            <a:spAutoFit/>
+          </a:bodyPr>
+          <a:lstStyle/>
+          <a:p>
+            <a:pPr algn="ctr"/>
+            <a:r>
+              <a:rPr sz="2000">
+                <a:solidFill>
+                  <a:srgbClr val="6B7280"/>
+                </a:solidFill>
+              </a:rPr>
+              <a:t>→</a:t>
+            </a:r>
+          </a:p>
+        </p:txBody>
+      </p:sp>
+      <p:sp>
+        <p:nvSpPr>
+          <p:cNvPr id="15" name="Rounded Rectangle 14"/>
+          <p:cNvSpPr/>
+          <p:nvPr/>
+        </p:nvSpPr>
+        <p:spPr>
+          <a:xfrm>
+            <a:off x="8055760" y="3650000"/>
+            <a:ext cx="1420000" cy="950000"/>
+          </a:xfrm>
+          <a:prstGeom prst="roundRect">
+            <a:avLst/>
+          </a:prstGeom>
+          <a:solidFill>
+            <a:srgbClr val="EF4444"/>
+          </a:solidFill>
+          <a:ln>
+            <a:solidFill>
+              <a:srgbClr val="EF4444"/>
+            </a:solidFill>
+          </a:ln>
+        </p:spPr>
+        <p:style>
+          <a:lnRef idx="1">
+            <a:schemeClr val="accent1"/>
+          </a:lnRef>
+          <a:fillRef idx="3">
+            <a:schemeClr val="accent1"/>
+          </a:fillRef>
+          <a:effectRef idx="2">
+            <a:schemeClr val="accent1"/>
+          </a:effectRef>
+          <a:fontRef idx="minor">
+            <a:schemeClr val="lt1"/>
+          </a:fontRef>
+        </p:style>
+        <p:txBody>
+          <a:bodyPr rtlCol="0" anchor="ctr" wrap="square"/>
+          <a:lstStyle/>
+          <a:p>
+            <a:pPr algn="ctr"/>
+            <a:r>
+              <a:rPr sz="1300" b="1">
+                <a:solidFill>
+                  <a:srgbClr val="FFFFFF"/>
+                </a:solidFill>
+              </a:rPr>
+              <a:t>Delete</a:t>
+            </a:r>
+          </a:p>
+          <a:p>
+            <a:pPr algn="ctr"/>
+            <a:r>
+              <a:rPr sz="800">
+                <a:solidFill>
+                  <a:srgbClr val="E5E7EB"/>
+                </a:solidFill>
+              </a:rPr>
+              <a:t>.delete()
+irreversible</a:t>
+            </a:r>
+          </a:p>
+        </p:txBody>
+      </p:sp>
+      <p:sp>
+        <p:nvSpPr>
+          <p:cNvPr id="16" name="TextBox 15"/>
+          <p:cNvSpPr txBox="1"/>
+          <p:nvPr/>
+        </p:nvSpPr>
+        <p:spPr>
+          <a:xfrm>
+            <a:off x="9505760" y="3945000"/>
+            <a:ext cx="310000" cy="360000"/>
+          </a:xfrm>
+          <a:prstGeom prst="rect">
+            <a:avLst/>
+          </a:prstGeom>
+          <a:noFill/>
+        </p:spPr>
+        <p:txBody>
+          <a:bodyPr wrap="none">
+            <a:spAutoFit/>
+          </a:bodyPr>
+          <a:lstStyle/>
+          <a:p>
+            <a:pPr algn="ctr"/>
+            <a:r>
+              <a:rPr sz="2000">
+                <a:solidFill>
+                  <a:srgbClr val="6B7280"/>
+                </a:solidFill>
+              </a:rPr>
+              <a:t>→</a:t>
+            </a:r>
+          </a:p>
+        </p:txBody>
+      </p:sp>
+      <p:sp>
+        <p:nvSpPr>
+          <p:cNvPr id="17" name="Rounded Rectangle 16"/>
+          <p:cNvSpPr/>
+          <p:nvPr/>
+        </p:nvSpPr>
+        <p:spPr>
+          <a:xfrm>
+            <a:off x="9845760" y="3650000"/>
+            <a:ext cx="1420000" cy="950000"/>
+          </a:xfrm>
+          <a:prstGeom prst="roundRect">
+            <a:avLst/>
+          </a:prstGeom>
+          <a:solidFill>
+            <a:srgbClr val="F59E0B"/>
+          </a:solidFill>
+          <a:ln>
+            <a:solidFill>
+              <a:srgbClr val="F59E0B"/>
+            </a:solidFill>
+          </a:ln>
+        </p:spPr>
+        <p:style>
+          <a:lnRef idx="1">
+            <a:schemeClr val="accent1"/>
+          </a:lnRef>
+          <a:fillRef idx="3">
+            <a:schemeClr val="accent1"/>
+          </a:fillRef>
+          <a:effectRef idx="2">
+            <a:schemeClr val="accent1"/>
+          </a:effectRef>
+          <a:fontRef idx="minor">
+            <a:schemeClr val="lt1"/>
+          </a:fontRef>
+        </p:style>
+        <p:txBody>
+          <a:bodyPr rtlCol="0" anchor="ctr" wrap="square"/>
+          <a:lstStyle/>
+          <a:p>
+            <a:pPr algn="ctr"/>
+            <a:r>
+              <a:rPr sz="1300" b="1">
+                <a:solidFill>
+                  <a:srgbClr val="FFFFFF"/>
+                </a:solidFill>
+              </a:rPr>
+              <a:t>Rollback</a:t>
+            </a:r>
+          </a:p>
+          <a:p>
+            <a:pPr algn="ctr"/>
+            <a:r>
+              <a:rPr sz="800">
+                <a:solidFill>
+                  <a:srgbClr val="E5E7EB"/>
+                </a:solidFill>
+              </a:rPr>
+              <a:t>prior
+resource_name</a:t>
+            </a:r>
+          </a:p>
+        </p:txBody>
+      </p:sp>
+      <p:sp>
+        <p:nvSpPr>
+          <p:cNvPr id="18" name="TextBox 17"/>
+          <p:cNvSpPr txBox="1"/>
+          <p:nvPr/>
+        </p:nvSpPr>
+        <p:spPr>
+          <a:xfrm>
+            <a:off x="548640" y="1294440"/>
+            <a:ext cx="11064240" cy="2250000"/>
           </a:xfrm>
           <a:prstGeom prst="rect">
             <a:avLst/>
@@ -4838,14 +5349,93 @@
           </a:bodyPr>
           <a:lstStyle/>
           <a:p>
-            <a:pPr algn="l"/>
-            <a:r>
-              <a:rPr sz="900" b="0">
-                <a:solidFill>
-                  <a:srgbClr val="A1A1AA"/>
-                </a:solidFill>
-              </a:rPr>
-              <a:t>academy.kspl.tech | Koenig AI Academy</a:t>
+            <a:pPr>
+              <a:spcAft>
+                <a:spcPts val="300"/>
+              </a:spcAft>
+            </a:pPr>
+            <a:r>
+              <a:rPr sz="1350">
+                <a:solidFill>
+                  <a:srgbClr val="FFFFFF"/>
+                </a:solidFill>
+              </a:rPr>
+              <a:t>▸  Package — build the .whl distribution; pin google-adk version in requirements.txt</a:t>
+            </a:r>
+          </a:p>
+          <a:p>
+            <a:pPr>
+              <a:spcAft>
+                <a:spcPts val="300"/>
+              </a:spcAft>
+            </a:pPr>
+            <a:r>
+              <a:rPr sz="1350">
+                <a:solidFill>
+                  <a:srgbClr val="FFFFFF"/>
+                </a:solidFill>
+              </a:rPr>
+              <a:t>▸  Create — deploy the wheel as a new agent resource; save resource_name</a:t>
+            </a:r>
+          </a:p>
+          <a:p>
+            <a:pPr>
+              <a:spcAft>
+                <a:spcPts val="300"/>
+              </a:spcAft>
+            </a:pPr>
+            <a:r>
+              <a:rPr sz="1350">
+                <a:solidFill>
+                  <a:srgbClr val="FFFFFF"/>
+                </a:solidFill>
+              </a:rPr>
+              <a:t>▸  Query — remote_agent.query() for sync; stream_query for streaming response as events arrive</a:t>
+            </a:r>
+          </a:p>
+          <a:p>
+            <a:pPr>
+              <a:spcAft>
+                <a:spcPts val="300"/>
+              </a:spcAft>
+            </a:pPr>
+            <a:r>
+              <a:rPr sz="1350">
+                <a:solidFill>
+                  <a:srgbClr val="FFFFFF"/>
+                </a:solidFill>
+              </a:rPr>
+              <a:t>▸  Update — push new wheel and pinned requirements when agent logic changes</a:t>
+            </a:r>
+          </a:p>
+          <a:p>
+            <a:pPr>
+              <a:spcAft>
+                <a:spcPts val="300"/>
+              </a:spcAft>
+            </a:pPr>
+            <a:r>
+              <a:rPr sz="1350">
+                <a:solidFill>
+                  <a:srgbClr val="FFFFFF"/>
+                </a:solidFill>
+              </a:rPr>
+              <a:t>▸  Delete — retire the compute resource; session records persist separately</a:t>
+            </a:r>
+          </a:p>
+          <a:p>
+            <a:pPr>
+              <a:spcAft>
+                <a:spcPts val="300"/>
+              </a:spcAft>
+            </a:pPr>
+            <a:r>
+              <a:rPr sz="1350">
+                <a:solidFill>
+                  <a:srgbClr val="FFFFFF"/>
+                </a:solidFill>
+              </a:rPr>
+              <a:t>▸  Rollback — redeploy a prior resource_name; session history is preserved across rollbacks</a:t>
             </a:r>
           </a:p>
         </p:txBody>
@@ -5671,40 +6261,6 @@
                 </a:solidFill>
               </a:rPr>
               <a:t>Chapter 3: Route inside one runtime with deterministic and LLM-mediated patterns</a:t>
-            </a:r>
-          </a:p>
-        </p:txBody>
-      </p:sp>
-      <p:sp>
-        <p:nvSpPr>
-          <p:cNvPr id="5" name="TextBox 4"/>
-          <p:cNvSpPr txBox="1"/>
-          <p:nvPr/>
-        </p:nvSpPr>
-        <p:spPr>
-          <a:xfrm>
-            <a:off x="914400" y="4114800"/>
-            <a:ext cx="10332720" cy="548640"/>
-          </a:xfrm>
-          <a:prstGeom prst="rect">
-            <a:avLst/>
-          </a:prstGeom>
-          <a:noFill/>
-        </p:spPr>
-        <p:txBody>
-          <a:bodyPr wrap="square">
-            <a:spAutoFit/>
-          </a:bodyPr>
-          <a:lstStyle/>
-          <a:p>
-            <a:pPr algn="ctr"/>
-            <a:r>
-              <a:rPr sz="2200" b="1">
-                <a:solidFill>
-                  <a:srgbClr val="6366F1"/>
-                </a:solidFill>
-              </a:rPr>
-              <a:t>academy.kspl.tech</a:t>
             </a:r>
           </a:p>
         </p:txBody>

</xml_diff>

<commit_message>
fix(slides): update ch02 speaker notes — six lifecycle operations
Slide 2 + Slide 10 notes had stale "five" counts after visual fix added
the 6th lifecycle step (Rollback). G0 blocker from KOEA-8302.

Co-Authored-By: Paperclip <noreply@paperclip.ing>
</commit_message>
<xml_diff>
--- a/vault/courses/gemini-enterprise-agents/ch02-slides.pptx
+++ b/vault/courses/gemini-enterprise-agents/ch02-slides.pptx
@@ -588,7 +588,7 @@
           <a:lstStyle/>
           <a:p>
             <a:r>
-              <a:t>The Agent Engine lifecycle has five explicit operations. Create was covered on the previous slide. The remaining four:
+              <a:t>The Agent Engine lifecycle has six explicit operations. Create was covered on the previous slide. The remaining five:
 Query invokes the deployed agent. Use remote_agent.query() for synchronous invocations where you wait for the full response. Use stream_query() for interactive applications where incremental output matters to the user — it returns a generator of events as they arrive over a streaming connection, in the same four-event pattern you observed locally.
 Update replaces the running container with a new version of your wheel. Queries in flight complete against the old container; new queries route to the updated version. There is no built-in traffic splitting on a single resource — if you need a canary deployment, create two resources and split at the client layer.
 Delete removes the compute resource but not the session records. Agent Engine Sessions persists independently. You must delete sessions via the sessions API separately if you need to purge user data.
@@ -954,7 +954,7 @@
           <a:lstStyle/>
           <a:p>
             <a:r>
-              <a:t>These five objectives map to the five sections of this chapter. Objectives 1 and 2 cover local development: build the agent and verify it works before touching any cloud infrastructure. Objective 3 is the deployment phase: wrap the agent in AdkApp, build a wheel, push it to Agent Engine. Objective 4 is the lifecycle walk-through: you will exercise all five lifecycle operations and learn that rollback is a re-create operation, not a native command. Objective 5 is the most important conceptual objective: in-process state is ephemeral, and Agent Engine Sessions is the durable store.
+              <a:t>These five objectives map to the five sections of this chapter. Objectives 1 and 2 cover local development: build the agent and verify it works before touching any cloud infrastructure. Objective 3 is the deployment phase: wrap the agent in AdkApp, build a wheel, push it to Agent Engine. Objective 4 is the lifecycle walk-through: you will exercise all six lifecycle operations and learn that rollback is a re-create operation, not a native command. Objective 5 is the most important conceptual objective: in-process state is ephemeral, and Agent Engine Sessions is the durable store.
 If you take nothing else from this chapter, take that distinction. Teams that treat the two state stores as equivalent produce agents that appear to work in development and fail silently in production when a container restarts. The failure is not an exception — the data is simply gone without warning.
 The hands-on exercise at the end ties all five objectives together with a single Policy Intake agent that you build, verify locally, deploy, query remotely, and validate for session continuity. The lifecycle comparison table you fill in during the exercise will be a reference you reach for throughout the rest of the course.</a:t>
             </a:r>

</xml_diff>